<commit_message>
split to pelagic/demersal rmds plus improvements
</commit_message>
<xml_diff>
--- a/_images/catchsamplingworkflow.pptx
+++ b/_images/catchsamplingworkflow.pptx
@@ -5213,4 +5213,254 @@
     </a:ext>
   </a:extLst>
 </a:theme>
+</file>
+
+<file path=customXml/item1.xml><?xml version="1.0" encoding="utf-8"?>
+<ct:contentTypeSchema xmlns:ct="http://schemas.microsoft.com/office/2006/metadata/contentType" xmlns:ma="http://schemas.microsoft.com/office/2006/metadata/properties/metaAttributes" ct:_="" ma:_="" ma:contentTypeName="Document" ma:contentTypeID="0x010100B79A833CF10F444BBAB252802BF889FD" ma:contentTypeVersion="13" ma:contentTypeDescription="Create a new document." ma:contentTypeScope="" ma:versionID="64f677fd2253f5247049a9cf21871e2a">
+  <xsd:schema xmlns:xsd="http://www.w3.org/2001/XMLSchema" xmlns:xs="http://www.w3.org/2001/XMLSchema" xmlns:p="http://schemas.microsoft.com/office/2006/metadata/properties" xmlns:ns2="c01e712b-8f9b-4625-8219-31b20605feb3" xmlns:ns3="2b166a80-dccc-42cc-be33-87bca7e0d87c" targetNamespace="http://schemas.microsoft.com/office/2006/metadata/properties" ma:root="true" ma:fieldsID="2fddc4c226a27c0868f3cab2348c32e7" ns2:_="" ns3:_="">
+    <xsd:import namespace="c01e712b-8f9b-4625-8219-31b20605feb3"/>
+    <xsd:import namespace="2b166a80-dccc-42cc-be33-87bca7e0d87c"/>
+    <xsd:element name="properties">
+      <xsd:complexType>
+        <xsd:sequence>
+          <xsd:element name="documentManagement">
+            <xsd:complexType>
+              <xsd:all>
+                <xsd:element ref="ns2:MediaServiceMetadata" minOccurs="0"/>
+                <xsd:element ref="ns2:MediaServiceFastMetadata" minOccurs="0"/>
+                <xsd:element ref="ns2:MediaServiceAutoKeyPoints" minOccurs="0"/>
+                <xsd:element ref="ns2:MediaServiceKeyPoints" minOccurs="0"/>
+                <xsd:element ref="ns2:MediaServiceDateTaken" minOccurs="0"/>
+                <xsd:element ref="ns2:MediaLengthInSeconds" minOccurs="0"/>
+                <xsd:element ref="ns2:MediaServiceAutoTags" minOccurs="0"/>
+                <xsd:element ref="ns2:MediaServiceOCR" minOccurs="0"/>
+                <xsd:element ref="ns2:MediaServiceGenerationTime" minOccurs="0"/>
+                <xsd:element ref="ns2:MediaServiceEventHashCode" minOccurs="0"/>
+                <xsd:element ref="ns2:MediaServiceLocation" minOccurs="0"/>
+                <xsd:element ref="ns3:SharedWithUsers" minOccurs="0"/>
+                <xsd:element ref="ns3:SharedWithDetails" minOccurs="0"/>
+              </xsd:all>
+            </xsd:complexType>
+          </xsd:element>
+        </xsd:sequence>
+      </xsd:complexType>
+    </xsd:element>
+  </xsd:schema>
+  <xsd:schema xmlns:xsd="http://www.w3.org/2001/XMLSchema" xmlns:xs="http://www.w3.org/2001/XMLSchema" xmlns:dms="http://schemas.microsoft.com/office/2006/documentManagement/types" xmlns:pc="http://schemas.microsoft.com/office/infopath/2007/PartnerControls" targetNamespace="c01e712b-8f9b-4625-8219-31b20605feb3" elementFormDefault="qualified">
+    <xsd:import namespace="http://schemas.microsoft.com/office/2006/documentManagement/types"/>
+    <xsd:import namespace="http://schemas.microsoft.com/office/infopath/2007/PartnerControls"/>
+    <xsd:element name="MediaServiceMetadata" ma:index="8" nillable="true" ma:displayName="MediaServiceMetadata" ma:hidden="true" ma:internalName="MediaServiceMetadata" ma:readOnly="true">
+      <xsd:simpleType>
+        <xsd:restriction base="dms:Note"/>
+      </xsd:simpleType>
+    </xsd:element>
+    <xsd:element name="MediaServiceFastMetadata" ma:index="9" nillable="true" ma:displayName="MediaServiceFastMetadata" ma:hidden="true" ma:internalName="MediaServiceFastMetadata" ma:readOnly="true">
+      <xsd:simpleType>
+        <xsd:restriction base="dms:Note"/>
+      </xsd:simpleType>
+    </xsd:element>
+    <xsd:element name="MediaServiceAutoKeyPoints" ma:index="10" nillable="true" ma:displayName="MediaServiceAutoKeyPoints" ma:hidden="true" ma:internalName="MediaServiceAutoKeyPoints" ma:readOnly="true">
+      <xsd:simpleType>
+        <xsd:restriction base="dms:Note"/>
+      </xsd:simpleType>
+    </xsd:element>
+    <xsd:element name="MediaServiceKeyPoints" ma:index="11" nillable="true" ma:displayName="KeyPoints" ma:internalName="MediaServiceKeyPoints" ma:readOnly="true">
+      <xsd:simpleType>
+        <xsd:restriction base="dms:Note">
+          <xsd:maxLength value="255"/>
+        </xsd:restriction>
+      </xsd:simpleType>
+    </xsd:element>
+    <xsd:element name="MediaServiceDateTaken" ma:index="12" nillable="true" ma:displayName="MediaServiceDateTaken" ma:hidden="true" ma:internalName="MediaServiceDateTaken" ma:readOnly="true">
+      <xsd:simpleType>
+        <xsd:restriction base="dms:Text"/>
+      </xsd:simpleType>
+    </xsd:element>
+    <xsd:element name="MediaLengthInSeconds" ma:index="13" nillable="true" ma:displayName="Length (seconds)" ma:internalName="MediaLengthInSeconds" ma:readOnly="true">
+      <xsd:simpleType>
+        <xsd:restriction base="dms:Unknown"/>
+      </xsd:simpleType>
+    </xsd:element>
+    <xsd:element name="MediaServiceAutoTags" ma:index="14" nillable="true" ma:displayName="Tags" ma:internalName="MediaServiceAutoTags" ma:readOnly="true">
+      <xsd:simpleType>
+        <xsd:restriction base="dms:Text"/>
+      </xsd:simpleType>
+    </xsd:element>
+    <xsd:element name="MediaServiceOCR" ma:index="15" nillable="true" ma:displayName="Extracted Text" ma:internalName="MediaServiceOCR" ma:readOnly="true">
+      <xsd:simpleType>
+        <xsd:restriction base="dms:Note">
+          <xsd:maxLength value="255"/>
+        </xsd:restriction>
+      </xsd:simpleType>
+    </xsd:element>
+    <xsd:element name="MediaServiceGenerationTime" ma:index="16" nillable="true" ma:displayName="MediaServiceGenerationTime" ma:hidden="true" ma:internalName="MediaServiceGenerationTime" ma:readOnly="true">
+      <xsd:simpleType>
+        <xsd:restriction base="dms:Text"/>
+      </xsd:simpleType>
+    </xsd:element>
+    <xsd:element name="MediaServiceEventHashCode" ma:index="17" nillable="true" ma:displayName="MediaServiceEventHashCode" ma:hidden="true" ma:internalName="MediaServiceEventHashCode" ma:readOnly="true">
+      <xsd:simpleType>
+        <xsd:restriction base="dms:Text"/>
+      </xsd:simpleType>
+    </xsd:element>
+    <xsd:element name="MediaServiceLocation" ma:index="18" nillable="true" ma:displayName="Location" ma:internalName="MediaServiceLocation" ma:readOnly="true">
+      <xsd:simpleType>
+        <xsd:restriction base="dms:Text"/>
+      </xsd:simpleType>
+    </xsd:element>
+  </xsd:schema>
+  <xsd:schema xmlns:xsd="http://www.w3.org/2001/XMLSchema" xmlns:xs="http://www.w3.org/2001/XMLSchema" xmlns:dms="http://schemas.microsoft.com/office/2006/documentManagement/types" xmlns:pc="http://schemas.microsoft.com/office/infopath/2007/PartnerControls" targetNamespace="2b166a80-dccc-42cc-be33-87bca7e0d87c" elementFormDefault="qualified">
+    <xsd:import namespace="http://schemas.microsoft.com/office/2006/documentManagement/types"/>
+    <xsd:import namespace="http://schemas.microsoft.com/office/infopath/2007/PartnerControls"/>
+    <xsd:element name="SharedWithUsers" ma:index="19" nillable="true" ma:displayName="Shared With" ma:internalName="SharedWithUsers" ma:readOnly="true">
+      <xsd:complexType>
+        <xsd:complexContent>
+          <xsd:extension base="dms:UserMulti">
+            <xsd:sequence>
+              <xsd:element name="UserInfo" minOccurs="0" maxOccurs="unbounded">
+                <xsd:complexType>
+                  <xsd:sequence>
+                    <xsd:element name="DisplayName" type="xsd:string" minOccurs="0"/>
+                    <xsd:element name="AccountId" type="dms:UserId" minOccurs="0" nillable="true"/>
+                    <xsd:element name="AccountType" type="xsd:string" minOccurs="0"/>
+                  </xsd:sequence>
+                </xsd:complexType>
+              </xsd:element>
+            </xsd:sequence>
+          </xsd:extension>
+        </xsd:complexContent>
+      </xsd:complexType>
+    </xsd:element>
+    <xsd:element name="SharedWithDetails" ma:index="20" nillable="true" ma:displayName="Shared With Details" ma:internalName="SharedWithDetails" ma:readOnly="true">
+      <xsd:simpleType>
+        <xsd:restriction base="dms:Note">
+          <xsd:maxLength value="255"/>
+        </xsd:restriction>
+      </xsd:simpleType>
+    </xsd:element>
+  </xsd:schema>
+  <xsd:schema xmlns="http://schemas.openxmlformats.org/package/2006/metadata/core-properties" xmlns:xsd="http://www.w3.org/2001/XMLSchema" xmlns:xsi="http://www.w3.org/2001/XMLSchema-instance" xmlns:dc="http://purl.org/dc/elements/1.1/" xmlns:dcterms="http://purl.org/dc/terms/" xmlns:odoc="http://schemas.microsoft.com/internal/obd" targetNamespace="http://schemas.openxmlformats.org/package/2006/metadata/core-properties" elementFormDefault="qualified" attributeFormDefault="unqualified" blockDefault="#all">
+    <xsd:import namespace="http://purl.org/dc/elements/1.1/" schemaLocation="http://dublincore.org/schemas/xmls/qdc/2003/04/02/dc.xsd"/>
+    <xsd:import namespace="http://purl.org/dc/terms/" schemaLocation="http://dublincore.org/schemas/xmls/qdc/2003/04/02/dcterms.xsd"/>
+    <xsd:element name="coreProperties" type="CT_coreProperties"/>
+    <xsd:complexType name="CT_coreProperties">
+      <xsd:all>
+        <xsd:element ref="dc:creator" minOccurs="0" maxOccurs="1"/>
+        <xsd:element ref="dcterms:created" minOccurs="0" maxOccurs="1"/>
+        <xsd:element ref="dc:identifier" minOccurs="0" maxOccurs="1"/>
+        <xsd:element name="contentType" minOccurs="0" maxOccurs="1" type="xsd:string" ma:index="0" ma:displayName="Content Type"/>
+        <xsd:element ref="dc:title" minOccurs="0" maxOccurs="1" ma:index="4" ma:displayName="Title"/>
+        <xsd:element ref="dc:subject" minOccurs="0" maxOccurs="1"/>
+        <xsd:element ref="dc:description" minOccurs="0" maxOccurs="1"/>
+        <xsd:element name="keywords" minOccurs="0" maxOccurs="1" type="xsd:string"/>
+        <xsd:element ref="dc:language" minOccurs="0" maxOccurs="1"/>
+        <xsd:element name="category" minOccurs="0" maxOccurs="1" type="xsd:string"/>
+        <xsd:element name="version" minOccurs="0" maxOccurs="1" type="xsd:string"/>
+        <xsd:element name="revision" minOccurs="0" maxOccurs="1" type="xsd:string">
+          <xsd:annotation>
+            <xsd:documentation>
+                        This value indicates the number of saves or revisions. The application is responsible for updating this value after each revision.
+                    </xsd:documentation>
+          </xsd:annotation>
+        </xsd:element>
+        <xsd:element name="lastModifiedBy" minOccurs="0" maxOccurs="1" type="xsd:string"/>
+        <xsd:element ref="dcterms:modified" minOccurs="0" maxOccurs="1"/>
+        <xsd:element name="contentStatus" minOccurs="0" maxOccurs="1" type="xsd:string"/>
+      </xsd:all>
+    </xsd:complexType>
+  </xsd:schema>
+  <xs:schema xmlns:pc="http://schemas.microsoft.com/office/infopath/2007/PartnerControls" xmlns:xs="http://www.w3.org/2001/XMLSchema" targetNamespace="http://schemas.microsoft.com/office/infopath/2007/PartnerControls" elementFormDefault="qualified" attributeFormDefault="unqualified">
+    <xs:element name="Person">
+      <xs:complexType>
+        <xs:sequence>
+          <xs:element ref="pc:DisplayName" minOccurs="0"/>
+          <xs:element ref="pc:AccountId" minOccurs="0"/>
+          <xs:element ref="pc:AccountType" minOccurs="0"/>
+        </xs:sequence>
+      </xs:complexType>
+    </xs:element>
+    <xs:element name="DisplayName" type="xs:string"/>
+    <xs:element name="AccountId" type="xs:string"/>
+    <xs:element name="AccountType" type="xs:string"/>
+    <xs:element name="BDCAssociatedEntity">
+      <xs:complexType>
+        <xs:sequence>
+          <xs:element ref="pc:BDCEntity" minOccurs="0" maxOccurs="unbounded"/>
+        </xs:sequence>
+        <xs:attribute ref="pc:EntityNamespace"/>
+        <xs:attribute ref="pc:EntityName"/>
+        <xs:attribute ref="pc:SystemInstanceName"/>
+        <xs:attribute ref="pc:AssociationName"/>
+      </xs:complexType>
+    </xs:element>
+    <xs:attribute name="EntityNamespace" type="xs:string"/>
+    <xs:attribute name="EntityName" type="xs:string"/>
+    <xs:attribute name="SystemInstanceName" type="xs:string"/>
+    <xs:attribute name="AssociationName" type="xs:string"/>
+    <xs:element name="BDCEntity">
+      <xs:complexType>
+        <xs:sequence>
+          <xs:element ref="pc:EntityDisplayName" minOccurs="0"/>
+          <xs:element ref="pc:EntityInstanceReference" minOccurs="0"/>
+          <xs:element ref="pc:EntityId1" minOccurs="0"/>
+          <xs:element ref="pc:EntityId2" minOccurs="0"/>
+          <xs:element ref="pc:EntityId3" minOccurs="0"/>
+          <xs:element ref="pc:EntityId4" minOccurs="0"/>
+          <xs:element ref="pc:EntityId5" minOccurs="0"/>
+        </xs:sequence>
+      </xs:complexType>
+    </xs:element>
+    <xs:element name="EntityDisplayName" type="xs:string"/>
+    <xs:element name="EntityInstanceReference" type="xs:string"/>
+    <xs:element name="EntityId1" type="xs:string"/>
+    <xs:element name="EntityId2" type="xs:string"/>
+    <xs:element name="EntityId3" type="xs:string"/>
+    <xs:element name="EntityId4" type="xs:string"/>
+    <xs:element name="EntityId5" type="xs:string"/>
+    <xs:element name="Terms">
+      <xs:complexType>
+        <xs:sequence>
+          <xs:element ref="pc:TermInfo" minOccurs="0" maxOccurs="unbounded"/>
+        </xs:sequence>
+      </xs:complexType>
+    </xs:element>
+    <xs:element name="TermInfo">
+      <xs:complexType>
+        <xs:sequence>
+          <xs:element ref="pc:TermName" minOccurs="0"/>
+          <xs:element ref="pc:TermId" minOccurs="0"/>
+        </xs:sequence>
+      </xs:complexType>
+    </xs:element>
+    <xs:element name="TermName" type="xs:string"/>
+    <xs:element name="TermId" type="xs:string"/>
+  </xs:schema>
+</ct:contentTypeSchema>
+</file>
+
+<file path=customXml/item2.xml><?xml version="1.0" encoding="utf-8"?>
+<?mso-contentType ?>
+<FormTemplates xmlns="http://schemas.microsoft.com/sharepoint/v3/contenttype/forms">
+  <Display>DocumentLibraryForm</Display>
+  <Edit>DocumentLibraryForm</Edit>
+  <New>DocumentLibraryForm</New>
+</FormTemplates>
+</file>
+
+<file path=customXml/item3.xml><?xml version="1.0" encoding="utf-8"?>
+<p:properties xmlns:p="http://schemas.microsoft.com/office/2006/metadata/properties" xmlns:xsi="http://www.w3.org/2001/XMLSchema-instance" xmlns:pc="http://schemas.microsoft.com/office/infopath/2007/PartnerControls">
+  <documentManagement/>
+</p:properties>
+</file>
+
+<file path=customXml/itemProps1.xml><?xml version="1.0" encoding="utf-8"?>
+<ds:datastoreItem xmlns:ds="http://schemas.openxmlformats.org/officeDocument/2006/customXml" ds:itemID="{D97905F4-3D47-463F-9DA1-CA6D37FC938C}"/>
+</file>
+
+<file path=customXml/itemProps2.xml><?xml version="1.0" encoding="utf-8"?>
+<ds:datastoreItem xmlns:ds="http://schemas.openxmlformats.org/officeDocument/2006/customXml" ds:itemID="{EF8CF7F2-AF22-46EE-89BD-3147FAB5A9CC}"/>
+</file>
+
+<file path=customXml/itemProps3.xml><?xml version="1.0" encoding="utf-8"?>
+<ds:datastoreItem xmlns:ds="http://schemas.openxmlformats.org/officeDocument/2006/customXml" ds:itemID="{BC7EDAC7-547A-4BBF-9B74-E65552FEE379}"/>
 </file>
</xml_diff>

<commit_message>
Correction of catchsamplingworkflow image
</commit_message>
<xml_diff>
--- a/_images/catchsamplingworkflow.pptx
+++ b/_images/catchsamplingworkflow.pptx
@@ -104,6 +104,11 @@
       </a:defRPr>
     </a:lvl9pPr>
   </p:defaultTextStyle>
+  <p:extLst>
+    <p:ext uri="{EFAFB233-063F-42B5-8137-9DF3F51BA10A}">
+      <p15:sldGuideLst xmlns:p15="http://schemas.microsoft.com/office/powerpoint/2012/main"/>
+    </p:ext>
+  </p:extLst>
 </p:presentation>
 </file>
 
@@ -3037,7 +3042,38 @@
                 <a:ea typeface="Calibri" panose="020F0502020204030204" pitchFamily="34" charset="0"/>
                 <a:cs typeface="Times New Roman" panose="02020603050405020304" pitchFamily="18" charset="0"/>
               </a:rPr>
-              <a:t>Pollutant -&gt; whole fish frozen</a:t>
+              <a:t>Pollutant </a:t>
+            </a:r>
+            <a:r>
+              <a:rPr kumimoji="0" lang="en-US" altLang="nb-NO" sz="1100" b="0" i="0" u="none" strike="noStrike" cap="none" normalizeH="0" baseline="0" dirty="0">
+                <a:ln>
+                  <a:noFill/>
+                </a:ln>
+                <a:solidFill>
+                  <a:schemeClr val="tx1"/>
+                </a:solidFill>
+                <a:effectLst/>
+                <a:latin typeface="Calibri" panose="020F0502020204030204" pitchFamily="34" charset="0"/>
+                <a:ea typeface="Calibri" panose="020F0502020204030204" pitchFamily="34" charset="0"/>
+                <a:cs typeface="Times New Roman" panose="02020603050405020304" pitchFamily="18" charset="0"/>
+                <a:sym typeface="Wingdings" panose="05000000000000000000" pitchFamily="2" charset="2"/>
+              </a:rPr>
+              <a:t></a:t>
+            </a:r>
+            <a:r>
+              <a:rPr kumimoji="0" lang="en-US" altLang="nb-NO" sz="1100" b="0" i="0" u="none" strike="noStrike" cap="none" normalizeH="0" baseline="0" dirty="0">
+                <a:ln>
+                  <a:noFill/>
+                </a:ln>
+                <a:solidFill>
+                  <a:schemeClr val="tx1"/>
+                </a:solidFill>
+                <a:effectLst/>
+                <a:latin typeface="Calibri" panose="020F0502020204030204" pitchFamily="34" charset="0"/>
+                <a:ea typeface="Calibri" panose="020F0502020204030204" pitchFamily="34" charset="0"/>
+                <a:cs typeface="Times New Roman" panose="02020603050405020304" pitchFamily="18" charset="0"/>
+              </a:rPr>
+              <a:t> whole fish frozen</a:t>
             </a:r>
             <a:endParaRPr kumimoji="0" lang="en-US" altLang="nb-NO" sz="1800" b="0" i="0" u="none" strike="noStrike" cap="none" normalizeH="0" baseline="0" dirty="0">
               <a:ln>
@@ -3123,7 +3159,38 @@
                 <a:ea typeface="Calibri" panose="020F0502020204030204" pitchFamily="34" charset="0"/>
                 <a:cs typeface="Times New Roman" panose="02020603050405020304" pitchFamily="18" charset="0"/>
               </a:rPr>
-              <a:t>Parasites -&gt; whole fish frozen</a:t>
+              <a:t>Parasites </a:t>
+            </a:r>
+            <a:r>
+              <a:rPr kumimoji="0" lang="en-US" altLang="nb-NO" sz="1100" b="0" i="0" u="none" strike="noStrike" cap="none" normalizeH="0" baseline="0" dirty="0">
+                <a:ln>
+                  <a:noFill/>
+                </a:ln>
+                <a:solidFill>
+                  <a:schemeClr val="tx1"/>
+                </a:solidFill>
+                <a:effectLst/>
+                <a:latin typeface="Calibri" panose="020F0502020204030204" pitchFamily="34" charset="0"/>
+                <a:ea typeface="Calibri" panose="020F0502020204030204" pitchFamily="34" charset="0"/>
+                <a:cs typeface="Times New Roman" panose="02020603050405020304" pitchFamily="18" charset="0"/>
+                <a:sym typeface="Wingdings" panose="05000000000000000000" pitchFamily="2" charset="2"/>
+              </a:rPr>
+              <a:t></a:t>
+            </a:r>
+            <a:r>
+              <a:rPr kumimoji="0" lang="en-US" altLang="nb-NO" sz="1100" b="0" i="0" u="none" strike="noStrike" cap="none" normalizeH="0" baseline="0" dirty="0">
+                <a:ln>
+                  <a:noFill/>
+                </a:ln>
+                <a:solidFill>
+                  <a:schemeClr val="tx1"/>
+                </a:solidFill>
+                <a:effectLst/>
+                <a:latin typeface="Calibri" panose="020F0502020204030204" pitchFamily="34" charset="0"/>
+                <a:ea typeface="Calibri" panose="020F0502020204030204" pitchFamily="34" charset="0"/>
+                <a:cs typeface="Times New Roman" panose="02020603050405020304" pitchFamily="18" charset="0"/>
+              </a:rPr>
+              <a:t> whole fish frozen</a:t>
             </a:r>
             <a:endParaRPr kumimoji="0" lang="en-US" altLang="nb-NO" sz="1800" b="0" i="0" u="none" strike="noStrike" cap="none" normalizeH="0" baseline="0" dirty="0">
               <a:ln>
@@ -3567,7 +3634,7 @@
                 </a:spcAft>
               </a:pPr>
               <a:r>
-                <a:rPr lang="en-US" sz="1100" b="1">
+                <a:rPr lang="en-US" sz="1100" b="1" dirty="0">
                   <a:solidFill>
                     <a:srgbClr val="FF0000"/>
                   </a:solidFill>
@@ -3579,15 +3646,15 @@
                 <a:t>3x10</a:t>
               </a:r>
               <a:r>
-                <a:rPr lang="en-US" sz="1100">
+                <a:rPr lang="en-US" sz="1100" dirty="0">
                   <a:effectLst/>
                   <a:latin typeface="Calibri" panose="020F0502020204030204" pitchFamily="34" charset="0"/>
                   <a:ea typeface="Calibri" panose="020F0502020204030204" pitchFamily="34" charset="0"/>
                   <a:cs typeface="Times New Roman" panose="02020603050405020304" pitchFamily="18" charset="0"/>
                 </a:rPr>
-                <a:t> 0</a:t>
+                <a:t> </a:t>
               </a:r>
-              <a:endParaRPr lang="nb-NO" sz="1100">
+              <a:endParaRPr lang="nb-NO" sz="1100" dirty="0">
                 <a:effectLst/>
                 <a:latin typeface="Calibri" panose="020F0502020204030204" pitchFamily="34" charset="0"/>
                 <a:ea typeface="Calibri" panose="020F0502020204030204" pitchFamily="34" charset="0"/>
@@ -3726,9 +3793,9 @@
         <p:grpSpPr>
           <a:xfrm>
             <a:off x="838940" y="1916112"/>
-            <a:ext cx="10907012" cy="4448175"/>
+            <a:ext cx="10941728" cy="4448175"/>
             <a:chOff x="-94569" y="0"/>
-            <a:chExt cx="10907012" cy="4448175"/>
+            <a:chExt cx="10941728" cy="4448175"/>
           </a:xfrm>
         </p:grpSpPr>
         <p:sp>
@@ -3746,7 +3813,7 @@
           <p:spPr>
             <a:xfrm>
               <a:off x="4533900" y="1666875"/>
-              <a:ext cx="2000250" cy="304800"/>
+              <a:ext cx="2025344" cy="304800"/>
             </a:xfrm>
             <a:prstGeom prst="rect">
               <a:avLst/>
@@ -3778,16 +3845,34 @@
                 </a:spcAft>
               </a:pPr>
               <a:r>
-                <a:rPr lang="en-US" sz="1100" i="1">
+                <a:rPr lang="en-US" sz="1100" i="1" dirty="0" err="1">
                   <a:effectLst/>
                   <a:latin typeface="Calibri" panose="020F0502020204030204" pitchFamily="34" charset="0"/>
                   <a:ea typeface="Calibri" panose="020F0502020204030204" pitchFamily="34" charset="0"/>
                   <a:cs typeface="Times New Roman" panose="02020603050405020304" pitchFamily="18" charset="0"/>
                 </a:rPr>
-                <a:t>Engraulis encasicolus</a:t>
+                <a:t>Engraulis</a:t>
               </a:r>
               <a:r>
-                <a:rPr lang="en-US" sz="1100">
+                <a:rPr lang="en-US" sz="1100" i="1" dirty="0">
+                  <a:effectLst/>
+                  <a:latin typeface="Calibri" panose="020F0502020204030204" pitchFamily="34" charset="0"/>
+                  <a:ea typeface="Calibri" panose="020F0502020204030204" pitchFamily="34" charset="0"/>
+                  <a:cs typeface="Times New Roman" panose="02020603050405020304" pitchFamily="18" charset="0"/>
+                </a:rPr>
+                <a:t> </a:t>
+              </a:r>
+              <a:r>
+                <a:rPr lang="en-US" sz="1100" i="1" dirty="0" err="1">
+                  <a:effectLst/>
+                  <a:latin typeface="Calibri" panose="020F0502020204030204" pitchFamily="34" charset="0"/>
+                  <a:ea typeface="Calibri" panose="020F0502020204030204" pitchFamily="34" charset="0"/>
+                  <a:cs typeface="Times New Roman" panose="02020603050405020304" pitchFamily="18" charset="0"/>
+                </a:rPr>
+                <a:t>encrasicolus</a:t>
+              </a:r>
+              <a:r>
+                <a:rPr lang="en-US" sz="1100" dirty="0">
                   <a:effectLst/>
                   <a:latin typeface="Calibri" panose="020F0502020204030204" pitchFamily="34" charset="0"/>
                   <a:ea typeface="Calibri" panose="020F0502020204030204" pitchFamily="34" charset="0"/>
@@ -3795,7 +3880,7 @@
                 </a:rPr>
                 <a:t> (anchovy)</a:t>
               </a:r>
-              <a:endParaRPr lang="nb-NO" sz="1100">
+              <a:endParaRPr lang="nb-NO" sz="1100" dirty="0">
                 <a:effectLst/>
                 <a:latin typeface="Calibri" panose="020F0502020204030204" pitchFamily="34" charset="0"/>
                 <a:ea typeface="Calibri" panose="020F0502020204030204" pitchFamily="34" charset="0"/>
@@ -3924,16 +4009,34 @@
                 </a:spcAft>
               </a:pPr>
               <a:r>
-                <a:rPr lang="en-US" sz="1100" i="1">
+                <a:rPr lang="en-US" sz="1100" i="1" dirty="0" err="1">
                   <a:effectLst/>
                   <a:latin typeface="Calibri" panose="020F0502020204030204" pitchFamily="34" charset="0"/>
                   <a:ea typeface="Calibri" panose="020F0502020204030204" pitchFamily="34" charset="0"/>
                   <a:cs typeface="Times New Roman" panose="02020603050405020304" pitchFamily="18" charset="0"/>
                 </a:rPr>
-                <a:t>Sardinops sagax</a:t>
+                <a:t>Sardinops</a:t>
               </a:r>
               <a:r>
-                <a:rPr lang="en-US" sz="1100">
+                <a:rPr lang="en-US" sz="1100" i="1" dirty="0">
+                  <a:effectLst/>
+                  <a:latin typeface="Calibri" panose="020F0502020204030204" pitchFamily="34" charset="0"/>
+                  <a:ea typeface="Calibri" panose="020F0502020204030204" pitchFamily="34" charset="0"/>
+                  <a:cs typeface="Times New Roman" panose="02020603050405020304" pitchFamily="18" charset="0"/>
+                </a:rPr>
+                <a:t> </a:t>
+              </a:r>
+              <a:r>
+                <a:rPr lang="en-US" sz="1100" i="1" dirty="0" err="1">
+                  <a:effectLst/>
+                  <a:latin typeface="Calibri" panose="020F0502020204030204" pitchFamily="34" charset="0"/>
+                  <a:ea typeface="Calibri" panose="020F0502020204030204" pitchFamily="34" charset="0"/>
+                  <a:cs typeface="Times New Roman" panose="02020603050405020304" pitchFamily="18" charset="0"/>
+                </a:rPr>
+                <a:t>sagax</a:t>
+              </a:r>
+              <a:r>
+                <a:rPr lang="en-US" sz="1100" dirty="0">
                   <a:effectLst/>
                   <a:latin typeface="Calibri" panose="020F0502020204030204" pitchFamily="34" charset="0"/>
                   <a:ea typeface="Calibri" panose="020F0502020204030204" pitchFamily="34" charset="0"/>
@@ -3941,7 +4044,7 @@
                 </a:rPr>
                 <a:t> (sardine)</a:t>
               </a:r>
-              <a:endParaRPr lang="nb-NO" sz="1100">
+              <a:endParaRPr lang="nb-NO" sz="1100" dirty="0">
                 <a:effectLst/>
                 <a:latin typeface="Calibri" panose="020F0502020204030204" pitchFamily="34" charset="0"/>
                 <a:ea typeface="Calibri" panose="020F0502020204030204" pitchFamily="34" charset="0"/>
@@ -4457,8 +4560,8 @@
           </p:nvSpPr>
           <p:spPr>
             <a:xfrm>
-              <a:off x="2186801" y="3896489"/>
-              <a:ext cx="1758930" cy="304800"/>
+              <a:off x="2186800" y="3896489"/>
+              <a:ext cx="1789041" cy="304800"/>
             </a:xfrm>
             <a:prstGeom prst="rect">
               <a:avLst/>
@@ -4496,7 +4599,26 @@
                   <a:ea typeface="Calibri" panose="020F0502020204030204" pitchFamily="34" charset="0"/>
                   <a:cs typeface="Times New Roman" panose="02020603050405020304" pitchFamily="18" charset="0"/>
                 </a:rPr>
-                <a:t>Biology -&gt; whole fish frozen</a:t>
+                <a:t>Biology </a:t>
+              </a:r>
+              <a:r>
+                <a:rPr lang="en-US" sz="1100" dirty="0">
+                  <a:effectLst/>
+                  <a:latin typeface="Calibri" panose="020F0502020204030204" pitchFamily="34" charset="0"/>
+                  <a:ea typeface="Calibri" panose="020F0502020204030204" pitchFamily="34" charset="0"/>
+                  <a:cs typeface="Times New Roman" panose="02020603050405020304" pitchFamily="18" charset="0"/>
+                  <a:sym typeface="Wingdings" panose="05000000000000000000" pitchFamily="2" charset="2"/>
+                </a:rPr>
+                <a:t></a:t>
+              </a:r>
+              <a:r>
+                <a:rPr lang="en-US" sz="1100" dirty="0">
+                  <a:effectLst/>
+                  <a:latin typeface="Calibri" panose="020F0502020204030204" pitchFamily="34" charset="0"/>
+                  <a:ea typeface="Calibri" panose="020F0502020204030204" pitchFamily="34" charset="0"/>
+                  <a:cs typeface="Times New Roman" panose="02020603050405020304" pitchFamily="18" charset="0"/>
+                </a:rPr>
+                <a:t> whole fish frozen</a:t>
               </a:r>
               <a:endParaRPr lang="nb-NO" sz="1100" dirty="0">
                 <a:effectLst/>
@@ -4622,12 +4744,38 @@
               </a:pPr>
               <a:r>
                 <a:rPr lang="en-US" sz="1100" dirty="0">
+                  <a:latin typeface="Calibri" panose="020F0502020204030204" pitchFamily="34" charset="0"/>
+                  <a:ea typeface="Calibri" panose="020F0502020204030204" pitchFamily="34" charset="0"/>
+                  <a:cs typeface="Times New Roman" panose="02020603050405020304" pitchFamily="18" charset="0"/>
+                </a:rPr>
+                <a:t>M</a:t>
+              </a:r>
+              <a:r>
+                <a:rPr lang="en-US" sz="1100" dirty="0">
                   <a:effectLst/>
                   <a:latin typeface="Calibri" panose="020F0502020204030204" pitchFamily="34" charset="0"/>
                   <a:ea typeface="Calibri" panose="020F0502020204030204" pitchFamily="34" charset="0"/>
                   <a:cs typeface="Times New Roman" panose="02020603050405020304" pitchFamily="18" charset="0"/>
                 </a:rPr>
-                <a:t>meristic -&gt; whole fish frozen</a:t>
+                <a:t>eristic </a:t>
+              </a:r>
+              <a:r>
+                <a:rPr lang="en-US" sz="1100" dirty="0">
+                  <a:latin typeface="Calibri" panose="020F0502020204030204" pitchFamily="34" charset="0"/>
+                  <a:ea typeface="Calibri" panose="020F0502020204030204" pitchFamily="34" charset="0"/>
+                  <a:cs typeface="Times New Roman" panose="02020603050405020304" pitchFamily="18" charset="0"/>
+                  <a:sym typeface="Wingdings" panose="05000000000000000000" pitchFamily="2" charset="2"/>
+                </a:rPr>
+                <a:t></a:t>
+              </a:r>
+              <a:r>
+                <a:rPr lang="en-US" sz="1100" dirty="0">
+                  <a:effectLst/>
+                  <a:latin typeface="Calibri" panose="020F0502020204030204" pitchFamily="34" charset="0"/>
+                  <a:ea typeface="Calibri" panose="020F0502020204030204" pitchFamily="34" charset="0"/>
+                  <a:cs typeface="Times New Roman" panose="02020603050405020304" pitchFamily="18" charset="0"/>
+                </a:rPr>
+                <a:t> whole fish frozen</a:t>
               </a:r>
               <a:endParaRPr lang="nb-NO" sz="1100" dirty="0">
                 <a:effectLst/>
@@ -4770,7 +4918,7 @@
           <p:spPr>
             <a:xfrm>
               <a:off x="8725925" y="1310162"/>
-              <a:ext cx="2086518" cy="276225"/>
+              <a:ext cx="2121234" cy="276225"/>
             </a:xfrm>
             <a:prstGeom prst="rect">
               <a:avLst/>
@@ -4808,9 +4956,28 @@
                   <a:ea typeface="Calibri" panose="020F0502020204030204" pitchFamily="34" charset="0"/>
                   <a:cs typeface="Times New Roman" panose="02020603050405020304" pitchFamily="18" charset="0"/>
                 </a:rPr>
-                <a:t>Micro-plastic -&gt; whole fish frozen</a:t>
+                <a:t>Microplastic </a:t>
               </a:r>
-              <a:endParaRPr lang="nb-NO" sz="1100">
+              <a:r>
+                <a:rPr lang="en-US" sz="1100" dirty="0">
+                  <a:effectLst/>
+                  <a:latin typeface="Calibri" panose="020F0502020204030204" pitchFamily="34" charset="0"/>
+                  <a:ea typeface="Calibri" panose="020F0502020204030204" pitchFamily="34" charset="0"/>
+                  <a:cs typeface="Times New Roman" panose="02020603050405020304" pitchFamily="18" charset="0"/>
+                  <a:sym typeface="Wingdings" panose="05000000000000000000" pitchFamily="2" charset="2"/>
+                </a:rPr>
+                <a:t></a:t>
+              </a:r>
+              <a:r>
+                <a:rPr lang="en-US" sz="1100" dirty="0">
+                  <a:effectLst/>
+                  <a:latin typeface="Calibri" panose="020F0502020204030204" pitchFamily="34" charset="0"/>
+                  <a:ea typeface="Calibri" panose="020F0502020204030204" pitchFamily="34" charset="0"/>
+                  <a:cs typeface="Times New Roman" panose="02020603050405020304" pitchFamily="18" charset="0"/>
+                </a:rPr>
+                <a:t> whole fish frozen</a:t>
+              </a:r>
+              <a:endParaRPr lang="nb-NO" sz="1100" dirty="0">
                 <a:effectLst/>
                 <a:latin typeface="Calibri" panose="020F0502020204030204" pitchFamily="34" charset="0"/>
                 <a:ea typeface="Calibri" panose="020F0502020204030204" pitchFamily="34" charset="0"/>
@@ -5068,9 +5235,9 @@
           <p:grpSpPr>
             <a:xfrm>
               <a:off x="638175" y="0"/>
-              <a:ext cx="7991475" cy="1181259"/>
+              <a:ext cx="7991475" cy="1064895"/>
               <a:chOff x="0" y="0"/>
-              <a:chExt cx="7991475" cy="1181259"/>
+              <a:chExt cx="7991475" cy="1064895"/>
             </a:xfrm>
           </p:grpSpPr>
           <p:sp>
@@ -5184,56 +5351,6 @@
                   <a:ea typeface="Calibri" panose="020F0502020204030204" pitchFamily="34" charset="0"/>
                   <a:cs typeface="Times New Roman" panose="02020603050405020304" pitchFamily="18" charset="0"/>
                 </a:endParaRPr>
-              </a:p>
-            </p:txBody>
-          </p:sp>
-          <p:sp>
-            <p:nvSpPr>
-              <p:cNvPr id="123" name="Arrow: Bent 122">
-                <a:extLst>
-                  <a:ext uri="{FF2B5EF4-FFF2-40B4-BE49-F238E27FC236}">
-                    <a16:creationId xmlns:a16="http://schemas.microsoft.com/office/drawing/2014/main" id="{F1C34568-58F9-4D4D-B22C-D0406EBBF467}"/>
-                  </a:ext>
-                </a:extLst>
-              </p:cNvPr>
-              <p:cNvSpPr/>
-              <p:nvPr/>
-            </p:nvSpPr>
-            <p:spPr>
-              <a:xfrm rot="5400000">
-                <a:off x="5459730" y="211455"/>
-                <a:ext cx="813435" cy="1126173"/>
-              </a:xfrm>
-              <a:prstGeom prst="bentArrow">
-                <a:avLst/>
-              </a:prstGeom>
-            </p:spPr>
-            <p:style>
-              <a:lnRef idx="2">
-                <a:schemeClr val="accent1">
-                  <a:shade val="50000"/>
-                </a:schemeClr>
-              </a:lnRef>
-              <a:fillRef idx="1">
-                <a:schemeClr val="accent1"/>
-              </a:fillRef>
-              <a:effectRef idx="0">
-                <a:schemeClr val="accent1"/>
-              </a:effectRef>
-              <a:fontRef idx="minor">
-                <a:schemeClr val="lt1"/>
-              </a:fontRef>
-            </p:style>
-            <p:txBody>
-              <a:bodyPr rot="0" spcFirstLastPara="0" vert="horz" wrap="square" lIns="91440" tIns="45720" rIns="91440" bIns="45720" numCol="1" spcCol="0" rtlCol="0" fromWordArt="0" anchor="ctr" anchorCtr="0" forceAA="0" compatLnSpc="1">
-                <a:prstTxWarp prst="textNoShape">
-                  <a:avLst/>
-                </a:prstTxWarp>
-                <a:noAutofit/>
-              </a:bodyPr>
-              <a:lstStyle/>
-              <a:p>
-                <a:endParaRPr lang="nb-NO"/>
               </a:p>
             </p:txBody>
           </p:sp>
@@ -5368,7 +5485,7 @@
             </p:nvSpPr>
             <p:spPr>
               <a:xfrm>
-                <a:off x="6391275" y="352425"/>
+                <a:off x="6305550" y="342900"/>
                 <a:ext cx="419100" cy="238125"/>
               </a:xfrm>
               <a:prstGeom prst="rect">
@@ -5401,7 +5518,7 @@
                   </a:spcAft>
                 </a:pPr>
                 <a:r>
-                  <a:rPr lang="en-US" sz="1100" b="1">
+                  <a:rPr lang="en-US" sz="1100" b="1" dirty="0">
                     <a:solidFill>
                       <a:srgbClr val="FF0000"/>
                     </a:solidFill>
@@ -5412,7 +5529,7 @@
                   </a:rPr>
                   <a:t>100</a:t>
                 </a:r>
-                <a:endParaRPr lang="nb-NO" sz="1100">
+                <a:endParaRPr lang="nb-NO" sz="1100" dirty="0">
                   <a:effectLst/>
                   <a:latin typeface="Calibri" panose="020F0502020204030204" pitchFamily="34" charset="0"/>
                   <a:ea typeface="Calibri" panose="020F0502020204030204" pitchFamily="34" charset="0"/>
@@ -5791,6 +5908,56 @@
               <a:t>workflow</a:t>
             </a:r>
             <a:endParaRPr lang="nb-NO" dirty="0"/>
+          </a:p>
+        </p:txBody>
+      </p:sp>
+      <p:sp>
+        <p:nvSpPr>
+          <p:cNvPr id="45" name="Arrow: Bent-Up 44">
+            <a:extLst>
+              <a:ext uri="{FF2B5EF4-FFF2-40B4-BE49-F238E27FC236}">
+                <a16:creationId xmlns:a16="http://schemas.microsoft.com/office/drawing/2014/main" id="{EB53DB35-A390-4760-B825-FAE6E99BF735}"/>
+              </a:ext>
+            </a:extLst>
+          </p:cNvPr>
+          <p:cNvSpPr/>
+          <p:nvPr/>
+        </p:nvSpPr>
+        <p:spPr>
+          <a:xfrm flipV="1">
+            <a:off x="6839009" y="2284864"/>
+            <a:ext cx="1047750" cy="731520"/>
+          </a:xfrm>
+          <a:prstGeom prst="bentUpArrow">
+            <a:avLst/>
+          </a:prstGeom>
+        </p:spPr>
+        <p:style>
+          <a:lnRef idx="2">
+            <a:schemeClr val="accent1">
+              <a:shade val="50000"/>
+            </a:schemeClr>
+          </a:lnRef>
+          <a:fillRef idx="1">
+            <a:schemeClr val="accent1"/>
+          </a:fillRef>
+          <a:effectRef idx="0">
+            <a:schemeClr val="accent1"/>
+          </a:effectRef>
+          <a:fontRef idx="minor">
+            <a:schemeClr val="lt1"/>
+          </a:fontRef>
+        </p:style>
+        <p:txBody>
+          <a:bodyPr rot="0" spcFirstLastPara="0" vert="horz" wrap="square" lIns="91440" tIns="45720" rIns="91440" bIns="45720" numCol="1" spcCol="0" rtlCol="0" fromWordArt="0" anchor="ctr" anchorCtr="0" forceAA="0" compatLnSpc="1">
+            <a:prstTxWarp prst="textNoShape">
+              <a:avLst/>
+            </a:prstTxWarp>
+            <a:noAutofit/>
+          </a:bodyPr>
+          <a:lstStyle/>
+          <a:p>
+            <a:endParaRPr lang="nb-NO"/>
           </a:p>
         </p:txBody>
       </p:sp>

</xml_diff>